<commit_message>
Deploying to gh-pages from @ Smithsonian/MitoPilot@39ef88745079a673193e52b77008c7e45edbee23 🚀
</commit_message>
<xml_diff>
--- a/reference/figures/workflow_overview.pptx
+++ b/reference/figures/workflow_overview.pptx
@@ -104,6 +104,11 @@
       </a:defRPr>
     </a:lvl9pPr>
   </p:defaultTextStyle>
+  <p:extLst>
+    <p:ext uri="{EFAFB233-063F-42B5-8137-9DF3F51BA10A}">
+      <p15:sldGuideLst xmlns:p15="http://schemas.microsoft.com/office/powerpoint/2012/main"/>
+    </p:ext>
+  </p:extLst>
 </p:presentation>
 </file>
 
@@ -254,7 +259,7 @@
           <a:p>
             <a:fld id="{FA095A4B-E0B2-984D-AE4F-72FF04A7AC22}" type="datetimeFigureOut">
               <a:rPr lang="en-US" smtClean="0"/>
-              <a:t>6/12/26</a:t>
+              <a:t>7/9/26</a:t>
             </a:fld>
             <a:endParaRPr lang="en-US"/>
           </a:p>
@@ -452,7 +457,7 @@
           <a:p>
             <a:fld id="{FA095A4B-E0B2-984D-AE4F-72FF04A7AC22}" type="datetimeFigureOut">
               <a:rPr lang="en-US" smtClean="0"/>
-              <a:t>6/12/26</a:t>
+              <a:t>7/9/26</a:t>
             </a:fld>
             <a:endParaRPr lang="en-US"/>
           </a:p>
@@ -660,7 +665,7 @@
           <a:p>
             <a:fld id="{FA095A4B-E0B2-984D-AE4F-72FF04A7AC22}" type="datetimeFigureOut">
               <a:rPr lang="en-US" smtClean="0"/>
-              <a:t>6/12/26</a:t>
+              <a:t>7/9/26</a:t>
             </a:fld>
             <a:endParaRPr lang="en-US"/>
           </a:p>
@@ -858,7 +863,7 @@
           <a:p>
             <a:fld id="{FA095A4B-E0B2-984D-AE4F-72FF04A7AC22}" type="datetimeFigureOut">
               <a:rPr lang="en-US" smtClean="0"/>
-              <a:t>6/12/26</a:t>
+              <a:t>7/9/26</a:t>
             </a:fld>
             <a:endParaRPr lang="en-US"/>
           </a:p>
@@ -1133,7 +1138,7 @@
           <a:p>
             <a:fld id="{FA095A4B-E0B2-984D-AE4F-72FF04A7AC22}" type="datetimeFigureOut">
               <a:rPr lang="en-US" smtClean="0"/>
-              <a:t>6/12/26</a:t>
+              <a:t>7/9/26</a:t>
             </a:fld>
             <a:endParaRPr lang="en-US"/>
           </a:p>
@@ -1398,7 +1403,7 @@
           <a:p>
             <a:fld id="{FA095A4B-E0B2-984D-AE4F-72FF04A7AC22}" type="datetimeFigureOut">
               <a:rPr lang="en-US" smtClean="0"/>
-              <a:t>6/12/26</a:t>
+              <a:t>7/9/26</a:t>
             </a:fld>
             <a:endParaRPr lang="en-US"/>
           </a:p>
@@ -1810,7 +1815,7 @@
           <a:p>
             <a:fld id="{FA095A4B-E0B2-984D-AE4F-72FF04A7AC22}" type="datetimeFigureOut">
               <a:rPr lang="en-US" smtClean="0"/>
-              <a:t>6/12/26</a:t>
+              <a:t>7/9/26</a:t>
             </a:fld>
             <a:endParaRPr lang="en-US"/>
           </a:p>
@@ -1951,7 +1956,7 @@
           <a:p>
             <a:fld id="{FA095A4B-E0B2-984D-AE4F-72FF04A7AC22}" type="datetimeFigureOut">
               <a:rPr lang="en-US" smtClean="0"/>
-              <a:t>6/12/26</a:t>
+              <a:t>7/9/26</a:t>
             </a:fld>
             <a:endParaRPr lang="en-US"/>
           </a:p>
@@ -2064,7 +2069,7 @@
           <a:p>
             <a:fld id="{FA095A4B-E0B2-984D-AE4F-72FF04A7AC22}" type="datetimeFigureOut">
               <a:rPr lang="en-US" smtClean="0"/>
-              <a:t>6/12/26</a:t>
+              <a:t>7/9/26</a:t>
             </a:fld>
             <a:endParaRPr lang="en-US"/>
           </a:p>
@@ -2375,7 +2380,7 @@
           <a:p>
             <a:fld id="{FA095A4B-E0B2-984D-AE4F-72FF04A7AC22}" type="datetimeFigureOut">
               <a:rPr lang="en-US" smtClean="0"/>
-              <a:t>6/12/26</a:t>
+              <a:t>7/9/26</a:t>
             </a:fld>
             <a:endParaRPr lang="en-US"/>
           </a:p>
@@ -2663,7 +2668,7 @@
           <a:p>
             <a:fld id="{FA095A4B-E0B2-984D-AE4F-72FF04A7AC22}" type="datetimeFigureOut">
               <a:rPr lang="en-US" smtClean="0"/>
-              <a:t>6/12/26</a:t>
+              <a:t>7/9/26</a:t>
             </a:fld>
             <a:endParaRPr lang="en-US"/>
           </a:p>
@@ -2904,7 +2909,7 @@
           <a:p>
             <a:fld id="{FA095A4B-E0B2-984D-AE4F-72FF04A7AC22}" type="datetimeFigureOut">
               <a:rPr lang="en-US" smtClean="0"/>
-              <a:t>6/12/26</a:t>
+              <a:t>7/9/26</a:t>
             </a:fld>
             <a:endParaRPr lang="en-US"/>
           </a:p>
@@ -5496,8 +5501,8 @@
         </p:nvSpPr>
         <p:spPr>
           <a:xfrm>
-            <a:off x="5571330" y="5196221"/>
-            <a:ext cx="2181453" cy="830997"/>
+            <a:off x="5448800" y="5196221"/>
+            <a:ext cx="2303983" cy="830997"/>
           </a:xfrm>
           <a:prstGeom prst="rect">
             <a:avLst/>
@@ -5512,6 +5517,14 @@
           <a:p>
             <a:pPr algn="ctr"/>
             <a:r>
+              <a:rPr lang="en-US" sz="1600" dirty="0">
+                <a:solidFill>
+                  <a:schemeClr val="bg1"/>
+                </a:solidFill>
+              </a:rPr>
+              <a:t>MITOS2, </a:t>
+            </a:r>
+            <a:r>
               <a:rPr lang="en-US" sz="1600" dirty="0" err="1">
                 <a:solidFill>
                   <a:schemeClr val="bg1"/>
@@ -5525,7 +5538,23 @@
                   <a:schemeClr val="bg1"/>
                 </a:solidFill>
               </a:rPr>
-              <a:t>-SE, MITOS2, ARWEN, ARAGORN, </a:t>
+              <a:t>-SE, </a:t>
+            </a:r>
+            <a:r>
+              <a:rPr lang="en-US" sz="1600" dirty="0" err="1">
+                <a:solidFill>
+                  <a:schemeClr val="bg1"/>
+                </a:solidFill>
+              </a:rPr>
+              <a:t>MitoFinder</a:t>
+            </a:r>
+            <a:r>
+              <a:rPr lang="en-US" sz="1600" dirty="0">
+                <a:solidFill>
+                  <a:schemeClr val="bg1"/>
+                </a:solidFill>
+              </a:rPr>
+              <a:t>, ARWEN, ARAGORN, </a:t>
             </a:r>
             <a:r>
               <a:rPr lang="en-US" sz="1600" dirty="0" err="1">

</xml_diff>